<commit_message>
#PIP-135 Mark module 3's screenshot as needing TIP, not partly available
slides.yaml called it "partial" because 6 of the notebook's 10 code cells ship
executed. That reading was wrong: the Query Browser is an ipywidget, so the
committed notebook holds a widget reference and no rendered state. The one thing
the slide is for — the SQL visible on screen — cannot be reconstructed offline.

The deck now says NEEDS A TIP RUN on that slide instead of the softer note, and
the session brief says why. Three placeholders remain and all three need TIP:
slides 3, 6 and 12, for modules 1, 3 and 5.

Co-Authored-By: Claude Opus 5 (1M context) <noreply@anthropic.com>
Claude-Session: https://claude.ai/code/session_018v8Qw2k7dKks33WedA2U9b
</commit_message>
<xml_diff>
--- a/9_documentation/course/TIP4PATLIBS_workshop.pptx
+++ b/9_documentation/course/TIP4PATLIBS_workshop.pptx
@@ -13717,13 +13717,13 @@
               </a:spcAft>
             </a:pPr>
             <a:r>
-              <a:rPr sz="1000" b="0" i="0">
-                <a:solidFill>
-                  <a:srgbClr val="94A3B8"/>
-                </a:solidFill>
-                <a:latin typeface="Arial"/>
-              </a:rPr>
-              <a:t>partly available — some cells ship cleared</a:t>
+              <a:rPr sz="1000" b="1" i="0">
+                <a:solidFill>
+                  <a:srgbClr val="BE0F05"/>
+                </a:solidFill>
+                <a:latin typeface="Arial"/>
+              </a:rPr>
+              <a:t>NEEDS A TIP RUN — notebook ships with cleared outputs</a:t>
             </a:r>
           </a:p>
         </p:txBody>

</xml_diff>

<commit_message>
Warsaw workshop: recut to 90 minutes around one claim (#24)
</commit_message>
<xml_diff>
--- a/9_documentation/course/TIP4PATLIBS_workshop.pptx
+++ b/9_documentation/course/TIP4PATLIBS_workshop.pptx
@@ -3207,7 +3207,7 @@
                 </a:solidFill>
                 <a:latin typeface="Arial"/>
               </a:rPr>
-              <a:t>Patent analytics on the EPO Technology Intelligence Platform</a:t>
+              <a:t>Install an assistant. Then ask better questions.</a:t>
             </a:r>
           </a:p>
           <a:p>
@@ -3226,7 +3226,7 @@
                 </a:solidFill>
                 <a:latin typeface="Arial"/>
               </a:rPr>
-              <a:t>PATLIB Workshop · Warsaw · 18 September 2026   ·   Arne Krüger · mtc.berlin</a:t>
+              <a:t>PATLIB Workshop · Warsaw · 18 September 2026   ·   Arne Krüger · mtc.berlin  ·  Riccardo Priore · AREA Science Park</a:t>
             </a:r>
           </a:p>
         </p:txBody>
@@ -3288,7 +3288,7 @@
                 </a:solidFill>
                 <a:latin typeface="Arial"/>
               </a:rPr>
-              <a:t>A PATLIB adviser can take a real question from a real client and answer it from PATSTAT on TIP — with a defensible method, a reproducible notebook and an artifact the client can keep. And they can say which parts of that answer are evidence and which are judgement.</a:t>
+              <a:t>You do not have to learn SQL. You have to install something that writes it — and then decide what to ask. Everything in this session is evidence for that one sentence.</a:t>
             </a:r>
           </a:p>
         </p:txBody>
@@ -3376,7 +3376,7 @@
                 </a:solidFill>
                 <a:latin typeface="Arial"/>
               </a:rPr>
-              <a:t>SKILLS</a:t>
+              <a:t>THE CLAIM</a:t>
             </a:r>
           </a:p>
         </p:txBody>
@@ -3389,7 +3389,7 @@
         </p:nvSpPr>
         <p:spPr>
           <a:xfrm>
-            <a:off x="978408" y="3767328"/>
+            <a:off x="978408" y="4599432"/>
             <a:ext cx="3803904" cy="694944"/>
           </a:xfrm>
           <a:prstGeom prst="roundRect">
@@ -3437,7 +3437,7 @@
         </p:nvSpPr>
         <p:spPr>
           <a:xfrm>
-            <a:off x="1161288" y="3867912"/>
+            <a:off x="1161288" y="4700016"/>
             <a:ext cx="3438144" cy="548640"/>
           </a:xfrm>
           <a:prstGeom prst="rect">
@@ -3466,7 +3466,7 @@
                 </a:solidFill>
                 <a:latin typeface="Arial"/>
               </a:rPr>
-              <a:t>1   Work on TIP at all</a:t>
+              <a:t>Install the assistant, persistently</a:t>
             </a:r>
           </a:p>
           <a:p>
@@ -3485,7 +3485,7 @@
                 </a:solidFill>
                 <a:latin typeface="Arial"/>
               </a:rPr>
-              <a:t>environment, first query</a:t>
+              <a:t>it writes the SQL and the notebooks — you decide what to ask</a:t>
             </a:r>
           </a:p>
         </p:txBody>
@@ -3498,7 +3498,95 @@
         </p:nvSpPr>
         <p:spPr>
           <a:xfrm>
-            <a:off x="978408" y="4599432"/>
+            <a:off x="6720840" y="3310128"/>
+            <a:ext cx="4206240" cy="2926080"/>
+          </a:xfrm>
+          <a:prstGeom prst="roundRect">
+            <a:avLst>
+              <a:gd name="adj" fmla="val 3000"/>
+            </a:avLst>
+          </a:prstGeom>
+          <a:noFill/>
+          <a:ln w="12700">
+            <a:solidFill>
+              <a:srgbClr val="E2E8F0"/>
+            </a:solidFill>
+          </a:ln>
+          <a:effectLst/>
+        </p:spPr>
+        <p:style>
+          <a:lnRef idx="1">
+            <a:schemeClr val="accent1"/>
+          </a:lnRef>
+          <a:fillRef idx="3">
+            <a:schemeClr val="accent1"/>
+          </a:fillRef>
+          <a:effectRef idx="2">
+            <a:schemeClr val="accent1"/>
+          </a:effectRef>
+          <a:fontRef idx="minor">
+            <a:schemeClr val="lt1"/>
+          </a:fontRef>
+        </p:style>
+        <p:txBody>
+          <a:bodyPr rtlCol="0" anchor="ctr" wrap="square"/>
+          <a:lstStyle/>
+          <a:p>
+            <a:pPr algn="ctr"/>
+          </a:p>
+        </p:txBody>
+      </p:sp>
+      <p:sp>
+        <p:nvSpPr>
+          <p:cNvPr id="10" name="TextBox 9"/>
+          <p:cNvSpPr txBox="1"/>
+          <p:nvPr/>
+        </p:nvSpPr>
+        <p:spPr>
+          <a:xfrm>
+            <a:off x="6720840" y="3438144"/>
+            <a:ext cx="4206240" cy="237744"/>
+          </a:xfrm>
+          <a:prstGeom prst="rect">
+            <a:avLst/>
+          </a:prstGeom>
+          <a:noFill/>
+        </p:spPr>
+        <p:txBody>
+          <a:bodyPr wrap="square" anchor="t" lIns="0" rIns="0" tIns="0" bIns="0">
+            <a:spAutoFit/>
+          </a:bodyPr>
+          <a:lstStyle/>
+          <a:p>
+            <a:pPr algn="ctr">
+              <a:lnSpc>
+                <a:spcPct val="125000"/>
+              </a:lnSpc>
+              <a:spcAft>
+                <a:spcPts val="0"/>
+              </a:spcAft>
+            </a:pPr>
+            <a:r>
+              <a:rPr sz="1000" b="1" i="0">
+                <a:solidFill>
+                  <a:srgbClr val="BE0F05"/>
+                </a:solidFill>
+                <a:latin typeface="Arial"/>
+              </a:rPr>
+              <a:t>THREE EXAMPLES, RISING</a:t>
+            </a:r>
+          </a:p>
+        </p:txBody>
+      </p:sp>
+      <p:sp>
+        <p:nvSpPr>
+          <p:cNvPr id="11" name="Rounded Rectangle 10"/>
+          <p:cNvSpPr/>
+          <p:nvPr/>
+        </p:nvSpPr>
+        <p:spPr>
+          <a:xfrm>
+            <a:off x="6922008" y="3767328"/>
             <a:ext cx="3803904" cy="694944"/>
           </a:xfrm>
           <a:prstGeom prst="roundRect">
@@ -3540,13 +3628,13 @@
       </p:sp>
       <p:sp>
         <p:nvSpPr>
-          <p:cNvPr id="10" name="TextBox 9"/>
-          <p:cNvSpPr txBox="1"/>
-          <p:nvPr/>
-        </p:nvSpPr>
-        <p:spPr>
-          <a:xfrm>
-            <a:off x="1161288" y="4700016"/>
+          <p:cNvPr id="12" name="TextBox 11"/>
+          <p:cNvSpPr txBox="1"/>
+          <p:nvPr/>
+        </p:nvSpPr>
+        <p:spPr>
+          <a:xfrm>
+            <a:off x="7104888" y="3867912"/>
             <a:ext cx="3438144" cy="548640"/>
           </a:xfrm>
           <a:prstGeom prst="rect">
@@ -3575,7 +3663,7 @@
                 </a:solidFill>
                 <a:latin typeface="Arial"/>
               </a:rPr>
-              <a:t>3   Ask PATSTAT a question</a:t>
+              <a:t>1   A question already asked</a:t>
             </a:r>
           </a:p>
           <a:p>
@@ -3601,13 +3689,13 @@
       </p:sp>
       <p:sp>
         <p:nvSpPr>
-          <p:cNvPr id="11" name="Rounded Rectangle 10"/>
+          <p:cNvPr id="13" name="Rounded Rectangle 12"/>
           <p:cNvSpPr/>
           <p:nvPr/>
         </p:nvSpPr>
         <p:spPr>
           <a:xfrm>
-            <a:off x="978408" y="5431536"/>
+            <a:off x="6922008" y="4599432"/>
             <a:ext cx="3803904" cy="694944"/>
           </a:xfrm>
           <a:prstGeom prst="roundRect">
@@ -3649,13 +3737,13 @@
       </p:sp>
       <p:sp>
         <p:nvSpPr>
-          <p:cNvPr id="12" name="TextBox 11"/>
-          <p:cNvSpPr txBox="1"/>
-          <p:nvPr/>
-        </p:nvSpPr>
-        <p:spPr>
-          <a:xfrm>
-            <a:off x="1161288" y="5532120"/>
+          <p:cNvPr id="14" name="TextBox 13"/>
+          <p:cNvSpPr txBox="1"/>
+          <p:nvPr/>
+        </p:nvSpPr>
+        <p:spPr>
+          <a:xfrm>
+            <a:off x="7104888" y="4700016"/>
             <a:ext cx="3438144" cy="548640"/>
           </a:xfrm>
           <a:prstGeom prst="rect">
@@ -3684,7 +3772,7 @@
                 </a:solidFill>
                 <a:latin typeface="Arial"/>
               </a:rPr>
-              <a:t>4   Find the right people</a:t>
+              <a:t>2   The same query, as an app</a:t>
             </a:r>
           </a:p>
           <a:p>
@@ -3703,95 +3791,7 @@
                 </a:solidFill>
                 <a:latin typeface="Arial"/>
               </a:rPr>
-              <a:t>applicant consolidation</a:t>
-            </a:r>
-          </a:p>
-        </p:txBody>
-      </p:sp>
-      <p:sp>
-        <p:nvSpPr>
-          <p:cNvPr id="13" name="Rounded Rectangle 12"/>
-          <p:cNvSpPr/>
-          <p:nvPr/>
-        </p:nvSpPr>
-        <p:spPr>
-          <a:xfrm>
-            <a:off x="6720840" y="3310128"/>
-            <a:ext cx="4206240" cy="2926080"/>
-          </a:xfrm>
-          <a:prstGeom prst="roundRect">
-            <a:avLst>
-              <a:gd name="adj" fmla="val 3000"/>
-            </a:avLst>
-          </a:prstGeom>
-          <a:noFill/>
-          <a:ln w="12700">
-            <a:solidFill>
-              <a:srgbClr val="E2E8F0"/>
-            </a:solidFill>
-          </a:ln>
-          <a:effectLst/>
-        </p:spPr>
-        <p:style>
-          <a:lnRef idx="1">
-            <a:schemeClr val="accent1"/>
-          </a:lnRef>
-          <a:fillRef idx="3">
-            <a:schemeClr val="accent1"/>
-          </a:fillRef>
-          <a:effectRef idx="2">
-            <a:schemeClr val="accent1"/>
-          </a:effectRef>
-          <a:fontRef idx="minor">
-            <a:schemeClr val="lt1"/>
-          </a:fontRef>
-        </p:style>
-        <p:txBody>
-          <a:bodyPr rtlCol="0" anchor="ctr" wrap="square"/>
-          <a:lstStyle/>
-          <a:p>
-            <a:pPr algn="ctr"/>
-          </a:p>
-        </p:txBody>
-      </p:sp>
-      <p:sp>
-        <p:nvSpPr>
-          <p:cNvPr id="14" name="TextBox 13"/>
-          <p:cNvSpPr txBox="1"/>
-          <p:nvPr/>
-        </p:nvSpPr>
-        <p:spPr>
-          <a:xfrm>
-            <a:off x="6720840" y="3438144"/>
-            <a:ext cx="4206240" cy="237744"/>
-          </a:xfrm>
-          <a:prstGeom prst="rect">
-            <a:avLst/>
-          </a:prstGeom>
-          <a:noFill/>
-        </p:spPr>
-        <p:txBody>
-          <a:bodyPr wrap="square" anchor="t" lIns="0" rIns="0" tIns="0" bIns="0">
-            <a:spAutoFit/>
-          </a:bodyPr>
-          <a:lstStyle/>
-          <a:p>
-            <a:pPr algn="ctr">
-              <a:lnSpc>
-                <a:spcPct val="125000"/>
-              </a:lnSpc>
-              <a:spcAft>
-                <a:spcPts val="0"/>
-              </a:spcAft>
-            </a:pPr>
-            <a:r>
-              <a:rPr sz="1000" b="1" i="0">
-                <a:solidFill>
-                  <a:srgbClr val="BE0F05"/>
-                </a:solidFill>
-                <a:latin typeface="Arial"/>
-              </a:rPr>
-              <a:t>APPLICATIONS</a:t>
+              <a:t>PATSTAT Explorer</a:t>
             </a:r>
           </a:p>
         </p:txBody>
@@ -3804,7 +3804,7 @@
         </p:nvSpPr>
         <p:spPr>
           <a:xfrm>
-            <a:off x="6922008" y="3767328"/>
+            <a:off x="6922008" y="5431536"/>
             <a:ext cx="3803904" cy="694944"/>
           </a:xfrm>
           <a:prstGeom prst="roundRect">
@@ -3852,224 +3852,6 @@
         </p:nvSpPr>
         <p:spPr>
           <a:xfrm>
-            <a:off x="7104888" y="3867912"/>
-            <a:ext cx="3438144" cy="548640"/>
-          </a:xfrm>
-          <a:prstGeom prst="rect">
-            <a:avLst/>
-          </a:prstGeom>
-          <a:noFill/>
-        </p:spPr>
-        <p:txBody>
-          <a:bodyPr wrap="square" anchor="t" lIns="0" rIns="0" tIns="0" bIns="0">
-            <a:spAutoFit/>
-          </a:bodyPr>
-          <a:lstStyle/>
-          <a:p>
-            <a:pPr algn="l">
-              <a:lnSpc>
-                <a:spcPct val="125000"/>
-              </a:lnSpc>
-              <a:spcAft>
-                <a:spcPts val="100"/>
-              </a:spcAft>
-            </a:pPr>
-            <a:r>
-              <a:rPr sz="1300" b="1" i="0">
-                <a:solidFill>
-                  <a:srgbClr val="1A1A1A"/>
-                </a:solidFill>
-                <a:latin typeface="Arial"/>
-              </a:rPr>
-              <a:t>5   Who is out there?</a:t>
-            </a:r>
-          </a:p>
-          <a:p>
-            <a:pPr algn="l">
-              <a:lnSpc>
-                <a:spcPct val="125000"/>
-              </a:lnSpc>
-              <a:spcAft>
-                <a:spcPts val="0"/>
-              </a:spcAft>
-            </a:pPr>
-            <a:r>
-              <a:rPr sz="1000" b="0" i="0">
-                <a:solidFill>
-                  <a:srgbClr val="64748B"/>
-                </a:solidFill>
-                <a:latin typeface="Arial"/>
-              </a:rPr>
-              <a:t>region → applicants → leads</a:t>
-            </a:r>
-          </a:p>
-        </p:txBody>
-      </p:sp>
-      <p:sp>
-        <p:nvSpPr>
-          <p:cNvPr id="17" name="Rounded Rectangle 16"/>
-          <p:cNvSpPr/>
-          <p:nvPr/>
-        </p:nvSpPr>
-        <p:spPr>
-          <a:xfrm>
-            <a:off x="6922008" y="4599432"/>
-            <a:ext cx="3803904" cy="694944"/>
-          </a:xfrm>
-          <a:prstGeom prst="roundRect">
-            <a:avLst>
-              <a:gd name="adj" fmla="val 12000"/>
-            </a:avLst>
-          </a:prstGeom>
-          <a:solidFill>
-            <a:srgbClr val="FDF2F2"/>
-          </a:solidFill>
-          <a:ln w="12700">
-            <a:solidFill>
-              <a:srgbClr val="BE0F05"/>
-            </a:solidFill>
-          </a:ln>
-          <a:effectLst/>
-        </p:spPr>
-        <p:style>
-          <a:lnRef idx="1">
-            <a:schemeClr val="accent1"/>
-          </a:lnRef>
-          <a:fillRef idx="3">
-            <a:schemeClr val="accent1"/>
-          </a:fillRef>
-          <a:effectRef idx="2">
-            <a:schemeClr val="accent1"/>
-          </a:effectRef>
-          <a:fontRef idx="minor">
-            <a:schemeClr val="lt1"/>
-          </a:fontRef>
-        </p:style>
-        <p:txBody>
-          <a:bodyPr rtlCol="0" anchor="ctr" wrap="square"/>
-          <a:lstStyle/>
-          <a:p>
-            <a:pPr algn="ctr"/>
-          </a:p>
-        </p:txBody>
-      </p:sp>
-      <p:sp>
-        <p:nvSpPr>
-          <p:cNvPr id="18" name="TextBox 17"/>
-          <p:cNvSpPr txBox="1"/>
-          <p:nvPr/>
-        </p:nvSpPr>
-        <p:spPr>
-          <a:xfrm>
-            <a:off x="7104888" y="4700016"/>
-            <a:ext cx="3438144" cy="548640"/>
-          </a:xfrm>
-          <a:prstGeom prst="rect">
-            <a:avLst/>
-          </a:prstGeom>
-          <a:noFill/>
-        </p:spPr>
-        <p:txBody>
-          <a:bodyPr wrap="square" anchor="t" lIns="0" rIns="0" tIns="0" bIns="0">
-            <a:spAutoFit/>
-          </a:bodyPr>
-          <a:lstStyle/>
-          <a:p>
-            <a:pPr algn="l">
-              <a:lnSpc>
-                <a:spcPct val="125000"/>
-              </a:lnSpc>
-              <a:spcAft>
-                <a:spcPts val="100"/>
-              </a:spcAft>
-            </a:pPr>
-            <a:r>
-              <a:rPr sz="1300" b="1" i="0">
-                <a:solidFill>
-                  <a:srgbClr val="1A1A1A"/>
-                </a:solidFill>
-                <a:latin typeface="Arial"/>
-              </a:rPr>
-              <a:t>6   What does a field look like?</a:t>
-            </a:r>
-          </a:p>
-          <a:p>
-            <a:pPr algn="l">
-              <a:lnSpc>
-                <a:spcPct val="125000"/>
-              </a:lnSpc>
-              <a:spcAft>
-                <a:spcPts val="0"/>
-              </a:spcAft>
-            </a:pPr>
-            <a:r>
-              <a:rPr sz="1000" b="0" i="0">
-                <a:solidFill>
-                  <a:srgbClr val="64748B"/>
-                </a:solidFill>
-                <a:latin typeface="Arial"/>
-              </a:rPr>
-              <a:t>corpus → analyses → report</a:t>
-            </a:r>
-          </a:p>
-        </p:txBody>
-      </p:sp>
-      <p:sp>
-        <p:nvSpPr>
-          <p:cNvPr id="19" name="Rounded Rectangle 18"/>
-          <p:cNvSpPr/>
-          <p:nvPr/>
-        </p:nvSpPr>
-        <p:spPr>
-          <a:xfrm>
-            <a:off x="6922008" y="5431536"/>
-            <a:ext cx="3803904" cy="694944"/>
-          </a:xfrm>
-          <a:prstGeom prst="roundRect">
-            <a:avLst>
-              <a:gd name="adj" fmla="val 12000"/>
-            </a:avLst>
-          </a:prstGeom>
-          <a:solidFill>
-            <a:srgbClr val="FDF2F2"/>
-          </a:solidFill>
-          <a:ln w="12700">
-            <a:solidFill>
-              <a:srgbClr val="BE0F05"/>
-            </a:solidFill>
-          </a:ln>
-          <a:effectLst/>
-        </p:spPr>
-        <p:style>
-          <a:lnRef idx="1">
-            <a:schemeClr val="accent1"/>
-          </a:lnRef>
-          <a:fillRef idx="3">
-            <a:schemeClr val="accent1"/>
-          </a:fillRef>
-          <a:effectRef idx="2">
-            <a:schemeClr val="accent1"/>
-          </a:effectRef>
-          <a:fontRef idx="minor">
-            <a:schemeClr val="lt1"/>
-          </a:fontRef>
-        </p:style>
-        <p:txBody>
-          <a:bodyPr rtlCol="0" anchor="ctr" wrap="square"/>
-          <a:lstStyle/>
-          <a:p>
-            <a:pPr algn="ctr"/>
-          </a:p>
-        </p:txBody>
-      </p:sp>
-      <p:sp>
-        <p:nvSpPr>
-          <p:cNvPr id="20" name="TextBox 19"/>
-          <p:cNvSpPr txBox="1"/>
-          <p:nvPr/>
-        </p:nvSpPr>
-        <p:spPr>
-          <a:xfrm>
             <a:off x="7104888" y="5532120"/>
             <a:ext cx="3438144" cy="548640"/>
           </a:xfrm>
@@ -4099,7 +3881,7 @@
                 </a:solidFill>
                 <a:latin typeface="Arial"/>
               </a:rPr>
-              <a:t>8   What is one patent worth?</a:t>
+              <a:t>3   Your region, your client list</a:t>
             </a:r>
           </a:p>
           <a:p>
@@ -4118,14 +3900,14 @@
                 </a:solidFill>
                 <a:latin typeface="Arial"/>
               </a:rPr>
-              <a:t>model → evidence → valuation</a:t>
-            </a:r>
-          </a:p>
-        </p:txBody>
-      </p:sp>
-      <p:sp>
-        <p:nvSpPr>
-          <p:cNvPr id="21" name="Right Arrow 20"/>
+              <a:t>regional leads — FR and DE</a:t>
+            </a:r>
+          </a:p>
+        </p:txBody>
+      </p:sp>
+      <p:sp>
+        <p:nvSpPr>
+          <p:cNvPr id="17" name="Right Arrow 16"/>
           <p:cNvSpPr/>
           <p:nvPr/>
         </p:nvSpPr>
@@ -4169,7 +3951,7 @@
       </p:sp>
       <p:sp>
         <p:nvSpPr>
-          <p:cNvPr id="22" name="TextBox 21"/>
+          <p:cNvPr id="18" name="TextBox 17"/>
           <p:cNvSpPr txBox="1"/>
           <p:nvPr/>
         </p:nvSpPr>
@@ -4204,15 +3986,15 @@
                 </a:solidFill>
                 <a:latin typeface="Arial"/>
               </a:rPr>
-              <a:t>each application
-consumes all three</a:t>
-            </a:r>
-          </a:p>
-        </p:txBody>
-      </p:sp>
-      <p:sp>
-        <p:nvSpPr>
-          <p:cNvPr id="23" name="TextBox 22"/>
+              <a:t>then, three
+times over</a:t>
+            </a:r>
+          </a:p>
+        </p:txBody>
+      </p:sp>
+      <p:sp>
+        <p:nvSpPr>
+          <p:cNvPr id="19" name="TextBox 18"/>
           <p:cNvSpPr txBox="1"/>
           <p:nvPr/>
         </p:nvSpPr>
@@ -4247,14 +4029,14 @@
                 </a:solidFill>
                 <a:latin typeface="Arial"/>
               </a:rPr>
-              <a:t>Each application consumes all three skills. 5, 6 and 8 are parallel, not sequential.</a:t>
-            </a:r>
-          </a:p>
-        </p:txBody>
-      </p:sp>
-      <p:sp>
-        <p:nvSpPr>
-          <p:cNvPr id="24" name="TextBox 23"/>
+              <a:t>Riccardo Priore adds two use cases of his own — 2 × 10 min</a:t>
+            </a:r>
+          </a:p>
+        </p:txBody>
+      </p:sp>
+      <p:sp>
+        <p:nvSpPr>
+          <p:cNvPr id="20" name="TextBox 19"/>
           <p:cNvSpPr txBox="1"/>
           <p:nvPr/>
         </p:nvSpPr>
@@ -4349,7 +4131,7 @@
                 </a:solidFill>
                 <a:latin typeface="Arial"/>
               </a:rPr>
-              <a:t>BLOCK A — SKILLS · MODULE 4</a:t>
+              <a:t>ARNE — THE CLAIM, THEN THE LADDER · MODULE 4</a:t>
             </a:r>
           </a:p>
         </p:txBody>
@@ -4869,7 +4651,7 @@
                 </a:solidFill>
                 <a:latin typeface="Arial"/>
               </a:rPr>
-              <a:t>BLOCK B — APPLICATIONS · MODULE 5</a:t>
+              <a:t>ARNE — THE CLAIM, THEN THE LADDER · MODULE 5</a:t>
             </a:r>
           </a:p>
         </p:txBody>
@@ -5417,7 +5199,7 @@
                 </a:solidFill>
                 <a:latin typeface="Arial"/>
               </a:rPr>
-              <a:t>BLOCK B — APPLICATIONS · MODULE 5</a:t>
+              <a:t>ARNE — THE CLAIM, THEN THE LADDER · MODULE 5</a:t>
             </a:r>
           </a:p>
         </p:txBody>
@@ -5459,7 +5241,7 @@
                 </a:solidFill>
                 <a:latin typeface="Arial"/>
               </a:rPr>
-              <a:t>Working through · ~28 min in the block</a:t>
+              <a:t>Rung 3 · 15 min</a:t>
             </a:r>
           </a:p>
         </p:txBody>
@@ -5790,7 +5572,7 @@
                 </a:solidFill>
                 <a:latin typeface="Arial"/>
               </a:rPr>
-              <a:t>7 min</a:t>
+              <a:t>5 min</a:t>
             </a:r>
           </a:p>
         </p:txBody>
@@ -5958,7 +5740,7 @@
                 </a:solidFill>
                 <a:latin typeface="Arial"/>
               </a:rPr>
-              <a:t>11 min</a:t>
+              <a:t>6 min</a:t>
             </a:r>
           </a:p>
         </p:txBody>
@@ -6126,7 +5908,7 @@
                 </a:solidFill>
                 <a:latin typeface="Arial"/>
               </a:rPr>
-              <a:t>6 min</a:t>
+              <a:t>4 min</a:t>
             </a:r>
           </a:p>
         </p:txBody>
@@ -6270,7 +6052,7 @@
                 </a:solidFill>
                 <a:latin typeface="Arial"/>
               </a:rPr>
-              <a:t>BLOCK B — APPLICATIONS · MODULE 5</a:t>
+              <a:t>ARNE — THE CLAIM, THEN THE LADDER · MODULE 5</a:t>
             </a:r>
           </a:p>
         </p:txBody>
@@ -6790,7 +6572,7 @@
                 </a:solidFill>
                 <a:latin typeface="Arial"/>
               </a:rPr>
-              <a:t>BLOCK B — APPLICATIONS · MODULE 6</a:t>
+              <a:t>RICCARDO — TWO USE CASES · MODULE 6</a:t>
             </a:r>
           </a:p>
         </p:txBody>
@@ -7380,7 +7162,7 @@
                 </a:solidFill>
                 <a:latin typeface="Arial"/>
               </a:rPr>
-              <a:t>BLOCK B — APPLICATIONS · MODULE 6</a:t>
+              <a:t>RICCARDO — TWO USE CASES · MODULE 6</a:t>
             </a:r>
           </a:p>
         </p:txBody>
@@ -7422,7 +7204,7 @@
                 </a:solidFill>
                 <a:latin typeface="Arial"/>
               </a:rPr>
-              <a:t>Working through · ~28 min in the block</a:t>
+              <a:t>Use case 1 · 10 min</a:t>
             </a:r>
           </a:p>
         </p:txBody>
@@ -7469,127 +7251,30 @@
           </a:p>
         </p:txBody>
       </p:sp>
-      <p:sp>
-        <p:nvSpPr>
-          <p:cNvPr id="5" name="Rounded Rectangle 4"/>
-          <p:cNvSpPr/>
-          <p:nvPr/>
-        </p:nvSpPr>
-        <p:spPr>
-          <a:xfrm>
-            <a:off x="777240" y="1737360"/>
-            <a:ext cx="6400800" cy="3977639"/>
-          </a:xfrm>
-          <a:prstGeom prst="roundRect">
-            <a:avLst>
-              <a:gd name="adj" fmla="val 2000"/>
-            </a:avLst>
-          </a:prstGeom>
-          <a:solidFill>
-            <a:srgbClr val="F8FAFC"/>
-          </a:solidFill>
-          <a:ln w="12700">
-            <a:solidFill>
-              <a:srgbClr val="E2E8F0"/>
-            </a:solidFill>
-          </a:ln>
-          <a:effectLst/>
-        </p:spPr>
-        <p:style>
-          <a:lnRef idx="1">
-            <a:schemeClr val="accent1"/>
-          </a:lnRef>
-          <a:fillRef idx="3">
-            <a:schemeClr val="accent1"/>
-          </a:fillRef>
-          <a:effectRef idx="2">
-            <a:schemeClr val="accent1"/>
-          </a:effectRef>
-          <a:fontRef idx="minor">
-            <a:schemeClr val="lt1"/>
-          </a:fontRef>
-        </p:style>
-        <p:txBody>
-          <a:bodyPr rtlCol="0" anchor="ctr" wrap="square" lIns="365760" rIns="365760"/>
-          <a:lstStyle/>
-          <a:p>
-            <a:pPr algn="ctr">
-              <a:lnSpc>
-                <a:spcPct val="125000"/>
-              </a:lnSpc>
-              <a:spcAft>
-                <a:spcPts val="1000"/>
-              </a:spcAft>
-            </a:pPr>
-            <a:r>
-              <a:rPr sz="1100" b="1" i="0">
-                <a:solidFill>
-                  <a:srgbClr val="94A3B8"/>
-                </a:solidFill>
-                <a:latin typeface="Arial"/>
-              </a:rPr>
-              <a:t>SCREENSHOT</a:t>
-            </a:r>
-          </a:p>
-          <a:p>
-            <a:pPr algn="ctr">
-              <a:lnSpc>
-                <a:spcPct val="125000"/>
-              </a:lnSpc>
-              <a:spcAft>
-                <a:spcPts val="1000"/>
-              </a:spcAft>
-            </a:pPr>
-            <a:r>
-              <a:rPr sz="1500" b="0" i="0">
-                <a:solidFill>
-                  <a:srgbClr val="1A1A1A"/>
-                </a:solidFill>
-                <a:latin typeface="Arial"/>
-              </a:rPr>
-              <a:t>The assembled report in Paged mode, on the applicants-by-sector chart</a:t>
-            </a:r>
-          </a:p>
-          <a:p>
-            <a:pPr algn="ctr">
-              <a:lnSpc>
-                <a:spcPct val="125000"/>
-              </a:lnSpc>
-              <a:spcAft>
-                <a:spcPts val="800"/>
-              </a:spcAft>
-            </a:pPr>
-            <a:r>
-              <a:rPr sz="1000" b="0" i="0">
-                <a:solidFill>
-                  <a:srgbClr val="64748B"/>
-                </a:solidFill>
-                <a:latin typeface="Arial"/>
-              </a:rPr>
-              <a:t>6_patentreports/2_antibiotic_resistance_rebuild/4_report/</a:t>
-            </a:r>
-          </a:p>
-          <a:p>
-            <a:pPr algn="ctr">
-              <a:lnSpc>
-                <a:spcPct val="125000"/>
-              </a:lnSpc>
-              <a:spcAft>
-                <a:spcPts val="0"/>
-              </a:spcAft>
-            </a:pPr>
-            <a:r>
-              <a:rPr sz="1000" b="0" i="0">
-                <a:solidFill>
-                  <a:srgbClr val="94A3B8"/>
-                </a:solidFill>
-                <a:latin typeface="Arial"/>
-              </a:rPr>
-              <a:t>available offline — notebook ships executed</a:t>
-            </a:r>
-          </a:p>
-        </p:txBody>
-      </p:sp>
+      <p:pic>
+        <p:nvPicPr>
+          <p:cNvPr id="5" name="Picture 4" descr="06.png"/>
+          <p:cNvPicPr>
+            <a:picLocks noChangeAspect="1"/>
+          </p:cNvPicPr>
+          <p:nvPr/>
+        </p:nvPicPr>
+        <p:blipFill>
+          <a:blip r:embed="rId2"/>
+          <a:stretch>
+            <a:fillRect/>
+          </a:stretch>
+        </p:blipFill>
+        <p:spPr>
+          <a:xfrm>
+            <a:off x="777240" y="2546396"/>
+            <a:ext cx="6400800" cy="2359567"/>
+          </a:xfrm>
+          <a:prstGeom prst="rect">
+            <a:avLst/>
+          </a:prstGeom>
+        </p:spPr>
+      </p:pic>
       <p:sp>
         <p:nvSpPr>
           <p:cNvPr id="6" name="Rounded Rectangle 5"/>
@@ -7753,7 +7438,7 @@
                 </a:solidFill>
                 <a:latin typeface="Arial"/>
               </a:rPr>
-              <a:t>10 min</a:t>
+              <a:t>3 min</a:t>
             </a:r>
           </a:p>
         </p:txBody>
@@ -7921,7 +7606,7 @@
                 </a:solidFill>
                 <a:latin typeface="Arial"/>
               </a:rPr>
-              <a:t>14 min</a:t>
+              <a:t>4 min</a:t>
             </a:r>
           </a:p>
         </p:txBody>
@@ -8089,7 +7774,7 @@
                 </a:solidFill>
                 <a:latin typeface="Arial"/>
               </a:rPr>
-              <a:t>4 min</a:t>
+              <a:t>3 min</a:t>
             </a:r>
           </a:p>
         </p:txBody>
@@ -8233,7 +7918,7 @@
                 </a:solidFill>
                 <a:latin typeface="Arial"/>
               </a:rPr>
-              <a:t>BLOCK B — APPLICATIONS · MODULE 6</a:t>
+              <a:t>RICCARDO — TWO USE CASES · MODULE 6</a:t>
             </a:r>
           </a:p>
         </p:txBody>
@@ -8753,7 +8438,7 @@
                 </a:solidFill>
                 <a:latin typeface="Arial"/>
               </a:rPr>
-              <a:t>BLOCK B — APPLICATIONS · MODULE 8</a:t>
+              <a:t>RICCARDO — TWO USE CASES · MODULE 8</a:t>
             </a:r>
           </a:p>
         </p:txBody>
@@ -9343,7 +9028,7 @@
                 </a:solidFill>
                 <a:latin typeface="Arial"/>
               </a:rPr>
-              <a:t>BLOCK B — APPLICATIONS · MODULE 8</a:t>
+              <a:t>RICCARDO — TWO USE CASES · MODULE 8</a:t>
             </a:r>
           </a:p>
         </p:txBody>
@@ -9385,7 +9070,7 @@
                 </a:solidFill>
                 <a:latin typeface="Arial"/>
               </a:rPr>
-              <a:t>Working through · ~28 min in the block</a:t>
+              <a:t>Use case 2 · 10 min</a:t>
             </a:r>
           </a:p>
         </p:txBody>
@@ -9432,127 +9117,30 @@
           </a:p>
         </p:txBody>
       </p:sp>
-      <p:sp>
-        <p:nvSpPr>
-          <p:cNvPr id="5" name="Rounded Rectangle 4"/>
-          <p:cNvSpPr/>
-          <p:nvPr/>
-        </p:nvSpPr>
-        <p:spPr>
-          <a:xfrm>
-            <a:off x="777240" y="1737360"/>
-            <a:ext cx="6400800" cy="3977639"/>
-          </a:xfrm>
-          <a:prstGeom prst="roundRect">
-            <a:avLst>
-              <a:gd name="adj" fmla="val 2000"/>
-            </a:avLst>
-          </a:prstGeom>
-          <a:solidFill>
-            <a:srgbClr val="F8FAFC"/>
-          </a:solidFill>
-          <a:ln w="12700">
-            <a:solidFill>
-              <a:srgbClr val="E2E8F0"/>
-            </a:solidFill>
-          </a:ln>
-          <a:effectLst/>
-        </p:spPr>
-        <p:style>
-          <a:lnRef idx="1">
-            <a:schemeClr val="accent1"/>
-          </a:lnRef>
-          <a:fillRef idx="3">
-            <a:schemeClr val="accent1"/>
-          </a:fillRef>
-          <a:effectRef idx="2">
-            <a:schemeClr val="accent1"/>
-          </a:effectRef>
-          <a:fontRef idx="minor">
-            <a:schemeClr val="lt1"/>
-          </a:fontRef>
-        </p:style>
-        <p:txBody>
-          <a:bodyPr rtlCol="0" anchor="ctr" wrap="square" lIns="365760" rIns="365760"/>
-          <a:lstStyle/>
-          <a:p>
-            <a:pPr algn="ctr">
-              <a:lnSpc>
-                <a:spcPct val="125000"/>
-              </a:lnSpc>
-              <a:spcAft>
-                <a:spcPts val="1000"/>
-              </a:spcAft>
-            </a:pPr>
-            <a:r>
-              <a:rPr sz="1100" b="1" i="0">
-                <a:solidFill>
-                  <a:srgbClr val="94A3B8"/>
-                </a:solidFill>
-                <a:latin typeface="Arial"/>
-              </a:rPr>
-              <a:t>SCREENSHOT</a:t>
-            </a:r>
-          </a:p>
-          <a:p>
-            <a:pPr algn="ctr">
-              <a:lnSpc>
-                <a:spcPct val="125000"/>
-              </a:lnSpc>
-              <a:spcAft>
-                <a:spcPts val="1000"/>
-              </a:spcAft>
-            </a:pPr>
-            <a:r>
-              <a:rPr sz="1500" b="0" i="0">
-                <a:solidFill>
-                  <a:srgbClr val="1A1A1A"/>
-                </a:solidFill>
-                <a:latin typeface="Arial"/>
-              </a:rPr>
-              <a:t>The report's verdict section — the number and the evidence split side by side</a:t>
-            </a:r>
-          </a:p>
-          <a:p>
-            <a:pPr algn="ctr">
-              <a:lnSpc>
-                <a:spcPct val="125000"/>
-              </a:lnSpc>
-              <a:spcAft>
-                <a:spcPts val="800"/>
-              </a:spcAft>
-            </a:pPr>
-            <a:r>
-              <a:rPr sz="1000" b="0" i="0">
-                <a:solidFill>
-                  <a:srgbClr val="64748B"/>
-                </a:solidFill>
-                <a:latin typeface="Arial"/>
-              </a:rPr>
-              <a:t>8_ipscore_rebuild/4_tool/ipscore_valuation.html</a:t>
-            </a:r>
-          </a:p>
-          <a:p>
-            <a:pPr algn="ctr">
-              <a:lnSpc>
-                <a:spcPct val="125000"/>
-              </a:lnSpc>
-              <a:spcAft>
-                <a:spcPts val="0"/>
-              </a:spcAft>
-            </a:pPr>
-            <a:r>
-              <a:rPr sz="1000" b="0" i="0">
-                <a:solidFill>
-                  <a:srgbClr val="94A3B8"/>
-                </a:solidFill>
-                <a:latin typeface="Arial"/>
-              </a:rPr>
-              <a:t>available offline — notebook ships executed</a:t>
-            </a:r>
-          </a:p>
-        </p:txBody>
-      </p:sp>
+      <p:pic>
+        <p:nvPicPr>
+          <p:cNvPr id="5" name="Picture 4" descr="08.png"/>
+          <p:cNvPicPr>
+            <a:picLocks noChangeAspect="1"/>
+          </p:cNvPicPr>
+          <p:nvPr/>
+        </p:nvPicPr>
+        <p:blipFill>
+          <a:blip r:embed="rId2"/>
+          <a:stretch>
+            <a:fillRect/>
+          </a:stretch>
+        </p:blipFill>
+        <p:spPr>
+          <a:xfrm>
+            <a:off x="777240" y="2367464"/>
+            <a:ext cx="6400800" cy="2717430"/>
+          </a:xfrm>
+          <a:prstGeom prst="rect">
+            <a:avLst/>
+          </a:prstGeom>
+        </p:spPr>
+      </p:pic>
       <p:sp>
         <p:nvSpPr>
           <p:cNvPr id="6" name="Rounded Rectangle 5"/>
@@ -9716,7 +9304,7 @@
                 </a:solidFill>
                 <a:latin typeface="Arial"/>
               </a:rPr>
-              <a:t>19 min</a:t>
+              <a:t>3 min</a:t>
             </a:r>
           </a:p>
         </p:txBody>
@@ -9884,7 +9472,7 @@
                 </a:solidFill>
                 <a:latin typeface="Arial"/>
               </a:rPr>
-              <a:t>6 min</a:t>
+              <a:t>4 min</a:t>
             </a:r>
           </a:p>
         </p:txBody>
@@ -10196,7 +9784,7 @@
                 </a:solidFill>
                 <a:latin typeface="Arial"/>
               </a:rPr>
-              <a:t>BLOCK B — APPLICATIONS · MODULE 8</a:t>
+              <a:t>RICCARDO — TWO USE CASES · MODULE 8</a:t>
             </a:r>
           </a:p>
         </p:txBody>
@@ -10716,7 +10304,7 @@
                 </a:solidFill>
                 <a:latin typeface="Arial"/>
               </a:rPr>
-              <a:t>BLOCK A — SKILLS · MODULE 1</a:t>
+              <a:t>ARNE — THE CLAIM, THEN THE LADDER · MODULE 1</a:t>
             </a:r>
           </a:p>
         </p:txBody>
@@ -10758,7 +10346,7 @@
                 </a:solidFill>
                 <a:latin typeface="Arial"/>
               </a:rPr>
-              <a:t>Module 1 — Start with TIP</a:t>
+              <a:t>Module 1 — Install the assistant, persistently</a:t>
             </a:r>
           </a:p>
         </p:txBody>
@@ -10820,7 +10408,7 @@
                 </a:solidFill>
                 <a:latin typeface="Arial"/>
               </a:rPr>
-              <a:t>"You have been given a login to a machine you do not own, which will be reset without warning, and which holds the largest patent database in the world. Where do you put your work?"</a:t>
+              <a:t>"You have a login to a machine you do not own, which is rebuilt without warning, and which holds the largest patent database in the world. How do you get an assistant onto it that is still there on Monday?"</a:t>
             </a:r>
           </a:p>
         </p:txBody>
@@ -10948,7 +10536,7 @@
                 </a:solidFill>
                 <a:latin typeface="Arial"/>
               </a:rPr>
-              <a:t>Half the room assumes everything persists, half assumes nothing does. Both are wrong.</a:t>
+              <a:t>"I will just install it." The naive install is gone by Monday — nothing was deleted, it was overwritten.</a:t>
             </a:r>
           </a:p>
         </p:txBody>
@@ -11034,7 +10622,7 @@
                 </a:solidFill>
                 <a:latin typeface="Arial"/>
               </a:rPr>
-              <a:t>It depends entirely on which directory — and nothing on the screen tells you which.</a:t>
+              <a:t>"Then I will learn SQL instead." That was the barrier for twenty years. It is the part that just stopped being hard.</a:t>
             </a:r>
           </a:p>
         </p:txBody>
@@ -11120,7 +10708,7 @@
                 </a:solidFill>
                 <a:latin typeface="Arial"/>
               </a:rPr>
-              <a:t>Nothing is deleted. It is overwritten, by the scripts that rebuild the container on every start.</a:t>
+              <a:t>"The assistant will get it wrong." Sometimes. Which is why the SQL it wrote stays on the screen, and you read it.</a:t>
             </a:r>
           </a:p>
         </p:txBody>
@@ -11308,7 +10896,7 @@
                 </a:solidFill>
                 <a:latin typeface="Arial"/>
               </a:rPr>
-              <a:t>What a participant leaves with</a:t>
+              <a:t>What you leave with</a:t>
             </a:r>
           </a:p>
         </p:txBody>
@@ -11394,7 +10982,7 @@
                 </a:solidFill>
                 <a:latin typeface="Arial"/>
               </a:rPr>
-              <a:t>Three skills: work on TIP · ask PATSTAT · find the right people</a:t>
+              <a:t>An assistant on TIP that survives the restart — and writes the SQL you were told you had to learn</a:t>
             </a:r>
           </a:p>
         </p:txBody>
@@ -11480,7 +11068,7 @@
                 </a:solidFill>
                 <a:latin typeface="Arial"/>
               </a:rPr>
-              <a:t>Three applications: a regional lead list · a landscape report · a patent valuation</a:t>
+              <a:t>Three worked examples, in rising order of ambition: a ready question · the same query as an app · a named shortlist for your own region</a:t>
             </a:r>
           </a:p>
         </p:txBody>
@@ -11566,14 +11154,100 @@
                 </a:solidFill>
                 <a:latin typeface="Arial"/>
               </a:rPr>
-              <a:t>And, in every one of them, the line between evidence and judgement — drawn out loud</a:t>
-            </a:r>
-          </a:p>
-        </p:txBody>
-      </p:sp>
-      <p:sp>
-        <p:nvSpPr>
-          <p:cNvPr id="10" name="Rounded Rectangle 9"/>
+              <a:t>Two use cases built the same way — a landscape report, and a patent valuation</a:t>
+            </a:r>
+          </a:p>
+        </p:txBody>
+      </p:sp>
+      <p:sp>
+        <p:nvSpPr>
+          <p:cNvPr id="10" name="Oval 9"/>
+          <p:cNvSpPr/>
+          <p:nvPr/>
+        </p:nvSpPr>
+        <p:spPr>
+          <a:xfrm>
+            <a:off x="777240" y="4800600"/>
+            <a:ext cx="109728" cy="109728"/>
+          </a:xfrm>
+          <a:prstGeom prst="ellipse">
+            <a:avLst/>
+          </a:prstGeom>
+          <a:solidFill>
+            <a:srgbClr val="BE0F05"/>
+          </a:solidFill>
+          <a:ln>
+            <a:noFill/>
+          </a:ln>
+          <a:effectLst/>
+        </p:spPr>
+        <p:style>
+          <a:lnRef idx="1">
+            <a:schemeClr val="accent1"/>
+          </a:lnRef>
+          <a:fillRef idx="3">
+            <a:schemeClr val="accent1"/>
+          </a:fillRef>
+          <a:effectRef idx="2">
+            <a:schemeClr val="accent1"/>
+          </a:effectRef>
+          <a:fontRef idx="minor">
+            <a:schemeClr val="lt1"/>
+          </a:fontRef>
+        </p:style>
+        <p:txBody>
+          <a:bodyPr rtlCol="0" anchor="ctr" wrap="square"/>
+          <a:lstStyle/>
+          <a:p>
+            <a:pPr algn="ctr"/>
+          </a:p>
+        </p:txBody>
+      </p:sp>
+      <p:sp>
+        <p:nvSpPr>
+          <p:cNvPr id="11" name="TextBox 10"/>
+          <p:cNvSpPr txBox="1"/>
+          <p:nvPr/>
+        </p:nvSpPr>
+        <p:spPr>
+          <a:xfrm>
+            <a:off x="1161288" y="4617720"/>
+            <a:ext cx="10253167" cy="640080"/>
+          </a:xfrm>
+          <a:prstGeom prst="rect">
+            <a:avLst/>
+          </a:prstGeom>
+          <a:noFill/>
+        </p:spPr>
+        <p:txBody>
+          <a:bodyPr wrap="square" anchor="t" lIns="0" rIns="0" tIns="0" bIns="0">
+            <a:spAutoFit/>
+          </a:bodyPr>
+          <a:lstStyle/>
+          <a:p>
+            <a:pPr algn="l">
+              <a:lnSpc>
+                <a:spcPct val="125000"/>
+              </a:lnSpc>
+              <a:spcAft>
+                <a:spcPts val="0"/>
+              </a:spcAft>
+            </a:pPr>
+            <a:r>
+              <a:rPr sz="1700" b="0" i="0">
+                <a:solidFill>
+                  <a:srgbClr val="1A1A1A"/>
+                </a:solidFill>
+                <a:latin typeface="Arial"/>
+              </a:rPr>
+              <a:t>And, in every one of them, the part no assistant does for you: deciding what to ask, and judging whether the answer holds</a:t>
+            </a:r>
+          </a:p>
+        </p:txBody>
+      </p:sp>
+      <p:sp>
+        <p:nvSpPr>
+          <p:cNvPr id="12" name="Rounded Rectangle 11"/>
           <p:cNvSpPr/>
           <p:nvPr/>
         </p:nvSpPr>
@@ -11628,7 +11302,7 @@
                 </a:solidFill>
                 <a:latin typeface="Arial"/>
               </a:rPr>
-              <a:t>Seven A4 handouts, one per module, in 9_documentation/course/</a:t>
+              <a:t>Seven A4 handouts — the full 45-minute version of every block you just saw — in 9_documentation/course/</a:t>
             </a:r>
           </a:p>
           <a:p>
@@ -11654,7 +11328,7 @@
       </p:sp>
       <p:sp>
         <p:nvSpPr>
-          <p:cNvPr id="11" name="TextBox 10"/>
+          <p:cNvPr id="13" name="TextBox 12"/>
           <p:cNvSpPr txBox="1"/>
           <p:nvPr/>
         </p:nvSpPr>
@@ -11689,14 +11363,14 @@
                 </a:solidFill>
                 <a:latin typeface="Arial"/>
               </a:rPr>
-              <a:t>Arne Krüger · mtc.berlin</a:t>
-            </a:r>
-          </a:p>
-        </p:txBody>
-      </p:sp>
-      <p:sp>
-        <p:nvSpPr>
-          <p:cNvPr id="12" name="TextBox 11"/>
+              <a:t>Arne Krüger · mtc.berlin  ·  Riccardo Priore · AREA Science Park</a:t>
+            </a:r>
+          </a:p>
+        </p:txBody>
+      </p:sp>
+      <p:sp>
+        <p:nvSpPr>
+          <p:cNvPr id="14" name="TextBox 13"/>
           <p:cNvSpPr txBox="1"/>
           <p:nvPr/>
         </p:nvSpPr>
@@ -11791,7 +11465,7 @@
                 </a:solidFill>
                 <a:latin typeface="Arial"/>
               </a:rPr>
-              <a:t>BLOCK A — SKILLS · MODULE 1</a:t>
+              <a:t>ARNE — THE CLAIM, THEN THE LADDER · MODULE 1</a:t>
             </a:r>
           </a:p>
         </p:txBody>
@@ -11833,7 +11507,7 @@
                 </a:solidFill>
                 <a:latin typeface="Arial"/>
               </a:rPr>
-              <a:t>Working through · ~28 min in the block</a:t>
+              <a:t>The claim · 15 min</a:t>
             </a:r>
           </a:p>
         </p:txBody>
@@ -11875,7 +11549,7 @@
                 </a:solidFill>
                 <a:latin typeface="Arial"/>
               </a:rPr>
-              <a:t>Start with TIP</a:t>
+              <a:t>Install the assistant, persistently</a:t>
             </a:r>
           </a:p>
         </p:txBody>
@@ -11958,7 +11632,7 @@
                 </a:solidFill>
                 <a:latin typeface="Arial"/>
               </a:rPr>
-              <a:t>Notebook 2, Query 1 — the applicant search with its result table</a:t>
+              <a:t>Claude Code running in the TIP terminal — a plain-language question, the SQL it wrote, the result</a:t>
             </a:r>
           </a:p>
           <a:p>
@@ -11977,7 +11651,7 @@
                 </a:solidFill>
                 <a:latin typeface="Arial"/>
               </a:rPr>
-              <a:t>1_startwithtip/2_getting-started-with-patstat.ipynb</a:t>
+              <a:t>1_startwithtip/1_getting-started-with-tip.ipynb</a:t>
             </a:r>
           </a:p>
           <a:p>
@@ -12126,7 +11800,7 @@
                 </a:solidFill>
                 <a:latin typeface="Arial"/>
               </a:rPr>
-              <a:t>Learn the machine</a:t>
+              <a:t>Where your work survives</a:t>
             </a:r>
           </a:p>
           <a:p>
@@ -12145,7 +11819,7 @@
                 </a:solidFill>
                 <a:latin typeface="Arial"/>
               </a:rPr>
-              <a:t>sections 1–5b — a factual report on your own environment</a:t>
+              <a:t>which directory persists, which is rebuilt on every start — and why nothing on screen tells you</a:t>
             </a:r>
           </a:p>
           <a:p>
@@ -12164,7 +11838,7 @@
                 </a:solidFill>
                 <a:latin typeface="Arial"/>
               </a:rPr>
-              <a:t>10 min</a:t>
+              <a:t>5 min</a:t>
             </a:r>
           </a:p>
         </p:txBody>
@@ -12294,7 +11968,7 @@
                 </a:solidFill>
                 <a:latin typeface="Arial"/>
               </a:rPr>
-              <a:t>Ask PATSTAT</a:t>
+              <a:t>Install it so it persists</a:t>
             </a:r>
           </a:p>
           <a:p>
@@ -12313,7 +11987,7 @@
                 </a:solidFill>
                 <a:latin typeface="Arial"/>
               </a:rPr>
-              <a:t>Part 1, queries 1–4 — your first result table</a:t>
+              <a:t>notebook 1, sections 6–8: the install, the settings, the status line</a:t>
             </a:r>
           </a:p>
           <a:p>
@@ -12332,7 +12006,7 @@
                 </a:solidFill>
                 <a:latin typeface="Arial"/>
               </a:rPr>
-              <a:t>13 min</a:t>
+              <a:t>7 min</a:t>
             </a:r>
           </a:p>
         </p:txBody>
@@ -12462,7 +12136,7 @@
                 </a:solidFill>
                 <a:latin typeface="Arial"/>
               </a:rPr>
-              <a:t>Get your work out</a:t>
+              <a:t>Ask it for a query</a:t>
             </a:r>
           </a:p>
           <a:p>
@@ -12481,7 +12155,7 @@
                 </a:solidFill>
                 <a:latin typeface="Arial"/>
               </a:rPr>
-              <a:t>sections 9–11 — SSH key, your own copy of the material</a:t>
+              <a:t>plain language in, SQL out, result table back — and you can read every line of it</a:t>
             </a:r>
           </a:p>
           <a:p>
@@ -12500,7 +12174,7 @@
                 </a:solidFill>
                 <a:latin typeface="Arial"/>
               </a:rPr>
-              <a:t>5 min</a:t>
+              <a:t>3 min</a:t>
             </a:r>
           </a:p>
         </p:txBody>
@@ -12644,7 +12318,7 @@
                 </a:solidFill>
                 <a:latin typeface="Arial"/>
               </a:rPr>
-              <a:t>BLOCK A — SKILLS · MODULE 1</a:t>
+              <a:t>ARNE — THE CLAIM, THEN THE LADDER · MODULE 1</a:t>
             </a:r>
           </a:p>
         </p:txBody>
@@ -12790,7 +12464,7 @@
                 </a:solidFill>
                 <a:latin typeface="Arial"/>
               </a:rPr>
-              <a:t>A TIP environment that survives a restart, with your settings in the right file</a:t>
+              <a:t>An assistant that is still installed after the machine restarts</a:t>
             </a:r>
           </a:p>
         </p:txBody>
@@ -12852,7 +12526,7 @@
                 </a:solidFill>
                 <a:latin typeface="Arial"/>
               </a:rPr>
-              <a:t>One PATSTAT query you wrote yourself, answering a question you chose</a:t>
+              <a:t>One query you did not write — and can read</a:t>
             </a:r>
           </a:p>
         </p:txBody>
@@ -12914,7 +12588,7 @@
                 </a:solidFill>
                 <a:latin typeface="Arial"/>
               </a:rPr>
-              <a:t>An SSH key that pushes your results off the machine</a:t>
+              <a:t>The setup that makes it yours, not a demonstration</a:t>
             </a:r>
           </a:p>
         </p:txBody>
@@ -13020,7 +12694,7 @@
                 </a:solidFill>
                 <a:latin typeface="Arial"/>
               </a:rPr>
-              <a:t>Count families for inventions and applications for filings — and always say which of the two you used.</a:t>
+              <a:t>The barrier was never the database. It was the SQL — and that is precisely the part you can now hand over.</a:t>
             </a:r>
           </a:p>
         </p:txBody>
@@ -13164,7 +12838,7 @@
                 </a:solidFill>
                 <a:latin typeface="Arial"/>
               </a:rPr>
-              <a:t>BLOCK A — SKILLS · MODULE 3</a:t>
+              <a:t>ARNE — THE CLAIM, THEN THE LADDER · MODULE 3</a:t>
             </a:r>
           </a:p>
         </p:txBody>
@@ -13712,7 +13386,7 @@
                 </a:solidFill>
                 <a:latin typeface="Arial"/>
               </a:rPr>
-              <a:t>BLOCK A — SKILLS · MODULE 3</a:t>
+              <a:t>ARNE — THE CLAIM, THEN THE LADDER · MODULE 3</a:t>
             </a:r>
           </a:p>
         </p:txBody>
@@ -13754,7 +13428,7 @@
                 </a:solidFill>
                 <a:latin typeface="Arial"/>
               </a:rPr>
-              <a:t>Working through · ~28 min in the block</a:t>
+              <a:t>Rung 1 · 8 min</a:t>
             </a:r>
           </a:p>
         </p:txBody>
@@ -13911,13 +13585,13 @@
               </a:spcAft>
             </a:pPr>
             <a:r>
-              <a:rPr sz="1000" b="0" i="0">
-                <a:solidFill>
-                  <a:srgbClr val="94A3B8"/>
-                </a:solidFill>
-                <a:latin typeface="Arial"/>
-              </a:rPr>
-              <a:t>partly available — some cells ship cleared</a:t>
+              <a:rPr sz="1000" b="1" i="0">
+                <a:solidFill>
+                  <a:srgbClr val="BE0F05"/>
+                </a:solidFill>
+                <a:latin typeface="Arial"/>
+              </a:rPr>
+              <a:t>NEEDS A TIP RUN — notebook ships with cleared outputs</a:t>
             </a:r>
           </a:p>
         </p:txBody>
@@ -14085,7 +13759,7 @@
                 </a:solidFill>
                 <a:latin typeface="Arial"/>
               </a:rPr>
-              <a:t>8 min</a:t>
+              <a:t>3 min</a:t>
             </a:r>
           </a:p>
         </p:txBody>
@@ -14253,7 +13927,7 @@
                 </a:solidFill>
                 <a:latin typeface="Arial"/>
               </a:rPr>
-              <a:t>12 min</a:t>
+              <a:t>3 min</a:t>
             </a:r>
           </a:p>
         </p:txBody>
@@ -14421,7 +14095,7 @@
                 </a:solidFill>
                 <a:latin typeface="Arial"/>
               </a:rPr>
-              <a:t>8 min</a:t>
+              <a:t>2 min</a:t>
             </a:r>
           </a:p>
         </p:txBody>
@@ -14565,7 +14239,7 @@
                 </a:solidFill>
                 <a:latin typeface="Arial"/>
               </a:rPr>
-              <a:t>BLOCK A — SKILLS · MODULE 3</a:t>
+              <a:t>ARNE — THE CLAIM, THEN THE LADDER · MODULE 3</a:t>
             </a:r>
           </a:p>
         </p:txBody>
@@ -15023,7 +14697,7 @@
                 </a:solidFill>
                 <a:latin typeface="Arial"/>
               </a:rPr>
-              <a:t>BLOCK A — SKILLS · MODULE 4</a:t>
+              <a:t>ARNE — THE CLAIM, THEN THE LADDER · MODULE 4</a:t>
             </a:r>
           </a:p>
         </p:txBody>
@@ -15571,7 +15245,7 @@
                 </a:solidFill>
                 <a:latin typeface="Arial"/>
               </a:rPr>
-              <a:t>BLOCK A — SKILLS · MODULE 4</a:t>
+              <a:t>ARNE — THE CLAIM, THEN THE LADDER · MODULE 4</a:t>
             </a:r>
           </a:p>
         </p:txBody>
@@ -15613,7 +15287,7 @@
                 </a:solidFill>
                 <a:latin typeface="Arial"/>
               </a:rPr>
-              <a:t>Working through · ~28 min in the block</a:t>
+              <a:t>Rung 2 · 10 min</a:t>
             </a:r>
           </a:p>
         </p:txBody>
@@ -15660,127 +15334,30 @@
           </a:p>
         </p:txBody>
       </p:sp>
-      <p:sp>
-        <p:nvSpPr>
-          <p:cNvPr id="5" name="Rounded Rectangle 4"/>
-          <p:cNvSpPr/>
-          <p:nvPr/>
-        </p:nvSpPr>
-        <p:spPr>
-          <a:xfrm>
-            <a:off x="777240" y="1737360"/>
-            <a:ext cx="6400800" cy="3977639"/>
-          </a:xfrm>
-          <a:prstGeom prst="roundRect">
-            <a:avLst>
-              <a:gd name="adj" fmla="val 2000"/>
-            </a:avLst>
-          </a:prstGeom>
-          <a:solidFill>
-            <a:srgbClr val="F8FAFC"/>
-          </a:solidFill>
-          <a:ln w="12700">
-            <a:solidFill>
-              <a:srgbClr val="E2E8F0"/>
-            </a:solidFill>
-          </a:ln>
-          <a:effectLst/>
-        </p:spPr>
-        <p:style>
-          <a:lnRef idx="1">
-            <a:schemeClr val="accent1"/>
-          </a:lnRef>
-          <a:fillRef idx="3">
-            <a:schemeClr val="accent1"/>
-          </a:fillRef>
-          <a:effectRef idx="2">
-            <a:schemeClr val="accent1"/>
-          </a:effectRef>
-          <a:fontRef idx="minor">
-            <a:schemeClr val="lt1"/>
-          </a:fontRef>
-        </p:style>
-        <p:txBody>
-          <a:bodyPr rtlCol="0" anchor="ctr" wrap="square" lIns="365760" rIns="365760"/>
-          <a:lstStyle/>
-          <a:p>
-            <a:pPr algn="ctr">
-              <a:lnSpc>
-                <a:spcPct val="125000"/>
-              </a:lnSpc>
-              <a:spcAft>
-                <a:spcPts val="1000"/>
-              </a:spcAft>
-            </a:pPr>
-            <a:r>
-              <a:rPr sz="1100" b="1" i="0">
-                <a:solidFill>
-                  <a:srgbClr val="94A3B8"/>
-                </a:solidFill>
-                <a:latin typeface="Arial"/>
-              </a:rPr>
-              <a:t>SCREENSHOT</a:t>
-            </a:r>
-          </a:p>
-          <a:p>
-            <a:pPr algn="ctr">
-              <a:lnSpc>
-                <a:spcPct val="125000"/>
-              </a:lnSpc>
-              <a:spcAft>
-                <a:spcPts val="1000"/>
-              </a:spcAft>
-            </a:pPr>
-            <a:r>
-              <a:rPr sz="1500" b="0" i="0">
-                <a:solidFill>
-                  <a:srgbClr val="1A1A1A"/>
-                </a:solidFill>
-                <a:latin typeface="Arial"/>
-              </a:rPr>
-              <a:t>The step-1 hit list — one company across many spellings</a:t>
-            </a:r>
-          </a:p>
-          <a:p>
-            <a:pPr algn="ctr">
-              <a:lnSpc>
-                <a:spcPct val="125000"/>
-              </a:lnSpc>
-              <a:spcAft>
-                <a:spcPts val="800"/>
-              </a:spcAft>
-            </a:pPr>
-            <a:r>
-              <a:rPr sz="1000" b="0" i="0">
-                <a:solidFill>
-                  <a:srgbClr val="64748B"/>
-                </a:solidFill>
-                <a:latin typeface="Arial"/>
-              </a:rPr>
-              <a:t>4_patstat_explorer/1_Applicant_consolidation_notebook.ipynb</a:t>
-            </a:r>
-          </a:p>
-          <a:p>
-            <a:pPr algn="ctr">
-              <a:lnSpc>
-                <a:spcPct val="125000"/>
-              </a:lnSpc>
-              <a:spcAft>
-                <a:spcPts val="0"/>
-              </a:spcAft>
-            </a:pPr>
-            <a:r>
-              <a:rPr sz="1000" b="0" i="0">
-                <a:solidFill>
-                  <a:srgbClr val="94A3B8"/>
-                </a:solidFill>
-                <a:latin typeface="Arial"/>
-              </a:rPr>
-              <a:t>available offline — notebook ships executed</a:t>
-            </a:r>
-          </a:p>
-        </p:txBody>
-      </p:sp>
+      <p:pic>
+        <p:nvPicPr>
+          <p:cNvPr id="5" name="Picture 4" descr="04.png"/>
+          <p:cNvPicPr>
+            <a:picLocks noChangeAspect="1"/>
+          </p:cNvPicPr>
+          <p:nvPr/>
+        </p:nvPicPr>
+        <p:blipFill>
+          <a:blip r:embed="rId2"/>
+          <a:stretch>
+            <a:fillRect/>
+          </a:stretch>
+        </p:blipFill>
+        <p:spPr>
+          <a:xfrm>
+            <a:off x="777240" y="2491116"/>
+            <a:ext cx="6400800" cy="2470126"/>
+          </a:xfrm>
+          <a:prstGeom prst="rect">
+            <a:avLst/>
+          </a:prstGeom>
+        </p:spPr>
+      </p:pic>
       <p:sp>
         <p:nvSpPr>
           <p:cNvPr id="6" name="Rounded Rectangle 5"/>
@@ -15944,7 +15521,7 @@
                 </a:solidFill>
                 <a:latin typeface="Arial"/>
               </a:rPr>
-              <a:t>6 min</a:t>
+              <a:t>3 min</a:t>
             </a:r>
           </a:p>
         </p:txBody>
@@ -16112,7 +15689,7 @@
                 </a:solidFill>
                 <a:latin typeface="Arial"/>
               </a:rPr>
-              <a:t>7 min</a:t>
+              <a:t>4 min</a:t>
             </a:r>
           </a:p>
         </p:txBody>
@@ -16280,7 +15857,7 @@
                 </a:solidFill>
                 <a:latin typeface="Arial"/>
               </a:rPr>
-              <a:t>7 min</a:t>
+              <a:t>3 min</a:t>
             </a:r>
           </a:p>
         </p:txBody>

</xml_diff>